<commit_message>
Corrige las diapositivas y añade el guion de la defensa
- Diapositivas: hosting InfinityFree (no DonDominio), URL https://algo.free.je
  y en las notas de cada diapositiva quién habla y cuánto tiempo.
- docs/Guion_defensa.md: guion de 7 minutos repartido entre los cuatro,
  con las preguntas más probables y la lista de pendientes.

Co-Authored-By: Claude Opus 5.5 <noreply@anthropic.com>
</commit_message>
<xml_diff>
--- a/docs/Diapositivas_NOCTILUZ.pptx
+++ b/docs/Diapositivas_NOCTILUZ.pptx
@@ -507,7 +507,7 @@
           <a:p>
             <a:r>
               <a:rPr lang="en-US" dirty="0"/>
-              <a:t>Presentar el caso en 30-40 s: qué vende NOCTILUZ, los tres criterios del catálogo y por qué el modo es una regla de negocio (no todas las prendas lo admiten). Decir quién ha hecho qué (debe coincidir con los commits). Cada integrante debe hablar un tiempo parecido: unos 1 min 45 s por persona.</a:t>
+              <a:t>Habla: Luis (diapositivas 1 y 2, ≈1:45). Guion completo en docs/Guion_defensa.md. Presentar el caso en 30-40 s: qué vende NOCTILUZ, los tres criterios del catálogo y por qué el modo es una regla de negocio (no todas las prendas lo admiten). Decir quién ha hecho qué (debe coincidir con los commits). Cada integrante debe hablar un tiempo parecido.</a:t>
             </a:r>
             <a:endParaRPr lang="en-US" dirty="0"/>
           </a:p>
@@ -683,7 +683,7 @@
           <a:p>
             <a:r>
               <a:rPr lang="en-US" dirty="0"/>
-              <a:t>Hacer la demo en la URL pública, no en local. Tener abiertas dos pestañas: tienda y back-office. Tras cada paso, refrescar la pestaña Eventos del back-office para enseñar que el evento aparece. Plan B si falla la red: vídeo corto grabado de antemano.</a:t>
+              <a:t>Hablan: Roberto (pasos 1-2, ≈0:45), Javier (pasos 3-5, ≈1:15) y JunJie (pasos 6-7, ≈0:45). Hacer la demo en la URL pública, no en local. Tener abiertas dos pestañas: tienda y back-office. Tras cada paso, refrescar la pestaña Eventos del back-office para enseñar que el evento aparece. Plan B si falla la red: vídeo corto grabado de antemano.</a:t>
             </a:r>
             <a:endParaRPr lang="en-US" dirty="0"/>
           </a:p>
@@ -771,7 +771,7 @@
           <a:p>
             <a:r>
               <a:rPr lang="en-US" dirty="0"/>
-              <a:t>Enseñar en phpMyAdmin las tablas pedidos, lineas_pedido, pagos, historial_estados y eventos con el pedido de la demo. Descargar el CSV de eventos. Explicar cómo lo consumiría otro sistema en la Tarea 2: pide GET eventos.php?desde_id=N y guarda el último id leído.</a:t>
+              <a:t>Habla: JunJie (≈0:45). Enseñar en phpMyAdmin las tablas pedidos, lineas_pedido, pagos, historial_estados y eventos con el pedido de la demo. Descargar el CSV de eventos. Explicar cómo lo consumiría otro sistema en la Tarea 2: pide GET eventos.php?desde_id=N y guarda el último id leído.</a:t>
             </a:r>
             <a:endParaRPr lang="en-US" dirty="0"/>
           </a:p>
@@ -859,7 +859,7 @@
           <a:p>
             <a:r>
               <a:rPr lang="en-US" dirty="0"/>
-              <a:t>Ser honestos con el uso de IA: qué hizo la IA, qué errores se le detectaron y cómo se validó. Preparar la respuesta a "¿por qué no WooCommerce?" y "¿qué pasa si dos personas compran la última unidad a la vez?" (UPDATE … WHERE stock &gt;= cantidad dentro de la transacción).</a:t>
+              <a:t>Habla: Luis (diapositivas 5 y 6, ≈1:15). Ser honestos con el uso de IA: qué hizo la IA, qué errores se le detectaron y cómo se validó. Preparar la respuesta a "¿por qué no WooCommerce?" y "¿qué pasa si dos personas compran la última unidad a la vez?" (UPDATE … WHERE stock &gt;= cantidad dentro de la transacción).</a:t>
             </a:r>
             <a:endParaRPr lang="en-US" dirty="0"/>
           </a:p>
@@ -2773,7 +2773,7 @@
                 <a:ea typeface="Segoe UI" pitchFamily="34" charset="-122"/>
                 <a:cs typeface="Segoe UI" pitchFamily="34" charset="-120"/>
               </a:rPr>
-              <a:t>Hosting DonDominio (Apache + PHP + MySQL) · el navegador nunca decide precios, impuestos ni stock</a:t>
+              <a:t>Hosting InfinityFree, provisional (Apache + PHP + MySQL) · el navegador nunca decide precios, impuestos ni stock</a:t>
             </a:r>
             <a:endParaRPr lang="en-US" sz="1300" dirty="0"/>
           </a:p>
@@ -4821,7 +4821,7 @@
                 <a:ea typeface="Segoe UI" pitchFamily="34" charset="-122"/>
                 <a:cs typeface="Segoe UI" pitchFamily="34" charset="-120"/>
               </a:rPr>
-              <a:t>URL: [COMPLETAR] · Back-office: /admin.html · admin@noctiluz.test</a:t>
+              <a:t>URL: https://algo.free.je · Back-office: /admin.html · admin@noctiluz.test</a:t>
             </a:r>
             <a:endParaRPr lang="en-US" sz="1200" dirty="0"/>
           </a:p>
@@ -5067,7 +5067,7 @@
       </p:sp>
       <p:pic>
         <p:nvPicPr>
-          <p:cNvPr id="8" name="Image 0" descr="C:\Users\FX517\AppData\Local\Temp\claude\C--Users-FX517-Documents-Smash\2079b400-4ed9-47a4-b7ee-87d689724b5f\scratchpad\docs\modelo_datos.png">    </p:cNvPr>
+          <p:cNvPr id="8" name="Image 0" descr="C:/Users/FX517/Documents/Trabajo de clase/Tarea 1 SDE/entrega_final/docs/modelo_datos.png">    </p:cNvPr>
           <p:cNvPicPr>
             <a:picLocks noChangeAspect="1"/>
           </p:cNvPicPr>

</xml_diff>

<commit_message>
Cambia la URL pública a noctiluz.free.je y ajusta la defensa al catálogo nuevo
- README, CLAUDE.md, COLABORAR.md, guion, diapositivas y memoria apuntan a https://noctiluz.free.je.
- Demo de la diapositiva 3 y del guion: "chaquetas + violeta + modo fijo" (con un solo modo por
  producto, el filtro con "degradado" ya no devolvía nada); el guion indica abrir el panel «Filtros».
- Memoria: la tabla de estados recoge que desde "pagado" y "en_preparacion" se puede pasar a
  enviado o entregado.

Co-Authored-By: Claude Opus 5.5 <noreply@anthropic.com>
</commit_message>
<xml_diff>
--- a/docs/Diapositivas_NOCTILUZ.pptx
+++ b/docs/Diapositivas_NOCTILUZ.pptx
@@ -2813,7 +2813,7 @@
                 <a:ea typeface="Segoe UI" pitchFamily="34" charset="-122"/>
                 <a:cs typeface="Segoe UI" pitchFamily="34" charset="-120"/>
               </a:rPr>
-              <a:t>Hosting InfinityFree, provisional (Apache + PHP + MySQL) · el navegador nunca decide precios, impuestos ni stock</a:t>
+              <a:t>Hosting InfinityFree (Apache + PHP + MySQL) · el navegador nunca decide precios, impuestos ni stock</a:t>
             </a:r>
             <a:endParaRPr lang="en-US" sz="1300" dirty="0"/>
           </a:p>
@@ -3967,7 +3967,7 @@
                 <a:ea typeface="Segoe UI" pitchFamily="34" charset="-122"/>
                 <a:cs typeface="Segoe UI" pitchFamily="34" charset="-120"/>
               </a:rPr>
-              <a:t>Filtrar: chaquetas + luz violeta + modo degradado</a:t>
+              <a:t>Filtrar: chaquetas + luz violeta + modo fijo</a:t>
             </a:r>
             <a:endParaRPr lang="en-US" sz="1500" dirty="0"/>
           </a:p>
@@ -4113,7 +4113,7 @@
                 <a:ea typeface="Segoe UI" pitchFamily="34" charset="-122"/>
                 <a:cs typeface="Segoe UI" pitchFamily="34" charset="-120"/>
               </a:rPr>
-              <a:t>Ficha: elegir modo y talla, añadir al carrito</a:t>
+              <a:t>Ficha: elegir talla, añadir al carrito</a:t>
             </a:r>
             <a:endParaRPr lang="en-US" sz="1500" dirty="0"/>
           </a:p>
@@ -4921,7 +4921,7 @@
                 <a:ea typeface="Segoe UI" pitchFamily="34" charset="-122"/>
                 <a:cs typeface="Segoe UI" pitchFamily="34" charset="-120"/>
               </a:rPr>
-              <a:t>URL: https://algo.free.je · Back-office: /admin.html · admin@noctiluz.test</a:t>
+              <a:t>URL: https://noctiluz.free.je · Back-office: /admin.html · admin@noctiluz.test</a:t>
             </a:r>
             <a:endParaRPr lang="en-US" sz="1200" dirty="0"/>
           </a:p>

</xml_diff>